<commit_message>
Using Cache With Pagination
</commit_message>
<xml_diff>
--- a/.lessons/26 Fundamental Cache/2 Storing Data In Cache/1.pptx
+++ b/.lessons/26 Fundamental Cache/2 Storing Data In Cache/1.pptx
@@ -269,7 +269,7 @@
           <a:p>
             <a:fld id="{3E102D2E-813C-461C-9963-687A650C48C0}" type="datetimeFigureOut">
               <a:rPr lang="en-US" smtClean="0"/>
-              <a:t>5/27/2025</a:t>
+              <a:t>5/29/2025</a:t>
             </a:fld>
             <a:endParaRPr lang="en-US"/>
           </a:p>
@@ -467,7 +467,7 @@
           <a:p>
             <a:fld id="{3E102D2E-813C-461C-9963-687A650C48C0}" type="datetimeFigureOut">
               <a:rPr lang="en-US" smtClean="0"/>
-              <a:t>5/27/2025</a:t>
+              <a:t>5/29/2025</a:t>
             </a:fld>
             <a:endParaRPr lang="en-US"/>
           </a:p>
@@ -675,7 +675,7 @@
           <a:p>
             <a:fld id="{3E102D2E-813C-461C-9963-687A650C48C0}" type="datetimeFigureOut">
               <a:rPr lang="en-US" smtClean="0"/>
-              <a:t>5/27/2025</a:t>
+              <a:t>5/29/2025</a:t>
             </a:fld>
             <a:endParaRPr lang="en-US"/>
           </a:p>
@@ -873,7 +873,7 @@
           <a:p>
             <a:fld id="{3E102D2E-813C-461C-9963-687A650C48C0}" type="datetimeFigureOut">
               <a:rPr lang="en-US" smtClean="0"/>
-              <a:t>5/27/2025</a:t>
+              <a:t>5/29/2025</a:t>
             </a:fld>
             <a:endParaRPr lang="en-US"/>
           </a:p>
@@ -1148,7 +1148,7 @@
           <a:p>
             <a:fld id="{3E102D2E-813C-461C-9963-687A650C48C0}" type="datetimeFigureOut">
               <a:rPr lang="en-US" smtClean="0"/>
-              <a:t>5/27/2025</a:t>
+              <a:t>5/29/2025</a:t>
             </a:fld>
             <a:endParaRPr lang="en-US"/>
           </a:p>
@@ -1413,7 +1413,7 @@
           <a:p>
             <a:fld id="{3E102D2E-813C-461C-9963-687A650C48C0}" type="datetimeFigureOut">
               <a:rPr lang="en-US" smtClean="0"/>
-              <a:t>5/27/2025</a:t>
+              <a:t>5/29/2025</a:t>
             </a:fld>
             <a:endParaRPr lang="en-US"/>
           </a:p>
@@ -1825,7 +1825,7 @@
           <a:p>
             <a:fld id="{3E102D2E-813C-461C-9963-687A650C48C0}" type="datetimeFigureOut">
               <a:rPr lang="en-US" smtClean="0"/>
-              <a:t>5/27/2025</a:t>
+              <a:t>5/29/2025</a:t>
             </a:fld>
             <a:endParaRPr lang="en-US"/>
           </a:p>
@@ -1966,7 +1966,7 @@
           <a:p>
             <a:fld id="{3E102D2E-813C-461C-9963-687A650C48C0}" type="datetimeFigureOut">
               <a:rPr lang="en-US" smtClean="0"/>
-              <a:t>5/27/2025</a:t>
+              <a:t>5/29/2025</a:t>
             </a:fld>
             <a:endParaRPr lang="en-US"/>
           </a:p>
@@ -2079,7 +2079,7 @@
           <a:p>
             <a:fld id="{3E102D2E-813C-461C-9963-687A650C48C0}" type="datetimeFigureOut">
               <a:rPr lang="en-US" smtClean="0"/>
-              <a:t>5/27/2025</a:t>
+              <a:t>5/29/2025</a:t>
             </a:fld>
             <a:endParaRPr lang="en-US"/>
           </a:p>
@@ -2390,7 +2390,7 @@
           <a:p>
             <a:fld id="{3E102D2E-813C-461C-9963-687A650C48C0}" type="datetimeFigureOut">
               <a:rPr lang="en-US" smtClean="0"/>
-              <a:t>5/27/2025</a:t>
+              <a:t>5/29/2025</a:t>
             </a:fld>
             <a:endParaRPr lang="en-US"/>
           </a:p>
@@ -2678,7 +2678,7 @@
           <a:p>
             <a:fld id="{3E102D2E-813C-461C-9963-687A650C48C0}" type="datetimeFigureOut">
               <a:rPr lang="en-US" smtClean="0"/>
-              <a:t>5/27/2025</a:t>
+              <a:t>5/29/2025</a:t>
             </a:fld>
             <a:endParaRPr lang="en-US"/>
           </a:p>
@@ -2919,7 +2919,7 @@
           <a:p>
             <a:fld id="{3E102D2E-813C-461C-9963-687A650C48C0}" type="datetimeFigureOut">
               <a:rPr lang="en-US" smtClean="0"/>
-              <a:t>5/27/2025</a:t>
+              <a:t>5/29/2025</a:t>
             </a:fld>
             <a:endParaRPr lang="en-US"/>
           </a:p>
@@ -3513,6 +3513,24 @@
               </a:lnSpc>
               <a:buNone/>
             </a:pPr>
+            <a:endParaRPr kumimoji="0" lang="en-US" altLang="en-US" sz="1300" b="0" i="0" u="none" strike="noStrike" cap="none" normalizeH="0" baseline="0">
+              <a:ln>
+                <a:noFill/>
+              </a:ln>
+              <a:solidFill>
+                <a:schemeClr val="tx1"/>
+              </a:solidFill>
+              <a:effectLst/>
+              <a:latin typeface="Arial" panose="020B0604020202020204" pitchFamily="34" charset="0"/>
+            </a:endParaRPr>
+          </a:p>
+          <a:p>
+            <a:pPr>
+              <a:lnSpc>
+                <a:spcPct val="150000"/>
+              </a:lnSpc>
+              <a:buNone/>
+            </a:pPr>
             <a:endParaRPr kumimoji="0" lang="az-Latn-AZ" altLang="en-US" sz="1300" b="0" i="0" u="none" strike="noStrike" cap="none" normalizeH="0" baseline="0">
               <a:ln>
                 <a:noFill/>
@@ -3531,24 +3549,6 @@
               </a:lnSpc>
               <a:buNone/>
             </a:pPr>
-            <a:endParaRPr kumimoji="0" lang="az-Latn-AZ" altLang="en-US" sz="1300" b="0" i="0" u="none" strike="noStrike" cap="none" normalizeH="0" baseline="0">
-              <a:ln>
-                <a:noFill/>
-              </a:ln>
-              <a:solidFill>
-                <a:schemeClr val="tx1"/>
-              </a:solidFill>
-              <a:effectLst/>
-              <a:latin typeface="Arial" panose="020B0604020202020204" pitchFamily="34" charset="0"/>
-            </a:endParaRPr>
-          </a:p>
-          <a:p>
-            <a:pPr>
-              <a:lnSpc>
-                <a:spcPct val="150000"/>
-              </a:lnSpc>
-              <a:buNone/>
-            </a:pPr>
             <a:r>
               <a:rPr lang="az-Latn-AZ" altLang="en-US" sz="1300">
                 <a:latin typeface="Arial" panose="020B0604020202020204" pitchFamily="34" charset="0"/>
@@ -3567,14 +3567,7 @@
               </a:rPr>
               <a:t> -sə birdən çox sorğunun daxil olduğunu görəcəyik ( 6 dənə ). </a:t>
             </a:r>
-            <a:endParaRPr kumimoji="0" lang="en-US" altLang="en-US" sz="1300" b="0" i="0" u="none" strike="noStrike" cap="none" normalizeH="0" baseline="0">
-              <a:ln>
-                <a:noFill/>
-              </a:ln>
-              <a:solidFill>
-                <a:schemeClr val="tx1"/>
-              </a:solidFill>
-              <a:effectLst/>
+            <a:endParaRPr lang="en-US" altLang="en-US" sz="1300">
               <a:latin typeface="Arial" panose="020B0604020202020204" pitchFamily="34" charset="0"/>
             </a:endParaRPr>
           </a:p>
@@ -4282,8 +4275,8 @@
         </p:nvSpPr>
         <p:spPr>
           <a:xfrm>
-            <a:off x="217714" y="255046"/>
-            <a:ext cx="11756571" cy="355354"/>
+            <a:off x="217715" y="255046"/>
+            <a:ext cx="6880670" cy="5756832"/>
           </a:xfrm>
           <a:prstGeom prst="rect">
             <a:avLst/>
@@ -4343,6 +4336,288 @@
                 <a:latin typeface="Arial" panose="020B0604020202020204" pitchFamily="34" charset="0"/>
               </a:rPr>
               <a:t>əlavə edə bilərik.</a:t>
+            </a:r>
+            <a:endParaRPr lang="en-US" altLang="en-US" sz="1300">
+              <a:latin typeface="Arial" panose="020B0604020202020204" pitchFamily="34" charset="0"/>
+            </a:endParaRPr>
+          </a:p>
+          <a:p>
+            <a:pPr>
+              <a:lnSpc>
+                <a:spcPct val="150000"/>
+              </a:lnSpc>
+              <a:buNone/>
+            </a:pPr>
+            <a:endParaRPr kumimoji="0" lang="az-Latn-AZ" altLang="en-US" sz="1300" b="0" i="0" u="none" strike="noStrike" cap="none" normalizeH="0" baseline="0">
+              <a:ln>
+                <a:noFill/>
+              </a:ln>
+              <a:solidFill>
+                <a:schemeClr val="tx1"/>
+              </a:solidFill>
+              <a:effectLst/>
+              <a:latin typeface="Arial" panose="020B0604020202020204" pitchFamily="34" charset="0"/>
+            </a:endParaRPr>
+          </a:p>
+          <a:p>
+            <a:pPr>
+              <a:lnSpc>
+                <a:spcPct val="150000"/>
+              </a:lnSpc>
+              <a:buNone/>
+            </a:pPr>
+            <a:endParaRPr lang="az-Latn-AZ" altLang="en-US" sz="1300">
+              <a:latin typeface="Arial" panose="020B0604020202020204" pitchFamily="34" charset="0"/>
+            </a:endParaRPr>
+          </a:p>
+          <a:p>
+            <a:pPr>
+              <a:lnSpc>
+                <a:spcPct val="150000"/>
+              </a:lnSpc>
+              <a:buNone/>
+            </a:pPr>
+            <a:endParaRPr kumimoji="0" lang="az-Latn-AZ" altLang="en-US" sz="1300" b="0" i="0" u="none" strike="noStrike" cap="none" normalizeH="0" baseline="0">
+              <a:ln>
+                <a:noFill/>
+              </a:ln>
+              <a:solidFill>
+                <a:schemeClr val="tx1"/>
+              </a:solidFill>
+              <a:effectLst/>
+              <a:latin typeface="Arial" panose="020B0604020202020204" pitchFamily="34" charset="0"/>
+            </a:endParaRPr>
+          </a:p>
+          <a:p>
+            <a:pPr>
+              <a:lnSpc>
+                <a:spcPct val="150000"/>
+              </a:lnSpc>
+              <a:buNone/>
+            </a:pPr>
+            <a:endParaRPr lang="az-Latn-AZ" altLang="en-US" sz="1300">
+              <a:latin typeface="Arial" panose="020B0604020202020204" pitchFamily="34" charset="0"/>
+            </a:endParaRPr>
+          </a:p>
+          <a:p>
+            <a:pPr>
+              <a:lnSpc>
+                <a:spcPct val="150000"/>
+              </a:lnSpc>
+              <a:buNone/>
+            </a:pPr>
+            <a:endParaRPr kumimoji="0" lang="az-Latn-AZ" altLang="en-US" sz="1300" b="0" i="0" u="none" strike="noStrike" cap="none" normalizeH="0" baseline="0">
+              <a:ln>
+                <a:noFill/>
+              </a:ln>
+              <a:solidFill>
+                <a:schemeClr val="tx1"/>
+              </a:solidFill>
+              <a:effectLst/>
+              <a:latin typeface="Arial" panose="020B0604020202020204" pitchFamily="34" charset="0"/>
+            </a:endParaRPr>
+          </a:p>
+          <a:p>
+            <a:pPr>
+              <a:lnSpc>
+                <a:spcPct val="150000"/>
+              </a:lnSpc>
+              <a:buNone/>
+            </a:pPr>
+            <a:endParaRPr lang="az-Latn-AZ" altLang="en-US" sz="1300">
+              <a:latin typeface="Arial" panose="020B0604020202020204" pitchFamily="34" charset="0"/>
+            </a:endParaRPr>
+          </a:p>
+          <a:p>
+            <a:pPr>
+              <a:lnSpc>
+                <a:spcPct val="150000"/>
+              </a:lnSpc>
+              <a:buNone/>
+            </a:pPr>
+            <a:endParaRPr kumimoji="0" lang="az-Latn-AZ" altLang="en-US" sz="1300" b="0" i="0" u="none" strike="noStrike" cap="none" normalizeH="0" baseline="0">
+              <a:ln>
+                <a:noFill/>
+              </a:ln>
+              <a:solidFill>
+                <a:schemeClr val="tx1"/>
+              </a:solidFill>
+              <a:effectLst/>
+              <a:latin typeface="Arial" panose="020B0604020202020204" pitchFamily="34" charset="0"/>
+            </a:endParaRPr>
+          </a:p>
+          <a:p>
+            <a:pPr>
+              <a:lnSpc>
+                <a:spcPct val="150000"/>
+              </a:lnSpc>
+              <a:buNone/>
+            </a:pPr>
+            <a:endParaRPr lang="az-Latn-AZ" altLang="en-US" sz="1300">
+              <a:latin typeface="Arial" panose="020B0604020202020204" pitchFamily="34" charset="0"/>
+            </a:endParaRPr>
+          </a:p>
+          <a:p>
+            <a:pPr>
+              <a:lnSpc>
+                <a:spcPct val="150000"/>
+              </a:lnSpc>
+              <a:buNone/>
+            </a:pPr>
+            <a:endParaRPr kumimoji="0" lang="az-Latn-AZ" altLang="en-US" sz="1300" b="0" i="0" u="none" strike="noStrike" cap="none" normalizeH="0" baseline="0">
+              <a:ln>
+                <a:noFill/>
+              </a:ln>
+              <a:solidFill>
+                <a:schemeClr val="tx1"/>
+              </a:solidFill>
+              <a:effectLst/>
+              <a:latin typeface="Arial" panose="020B0604020202020204" pitchFamily="34" charset="0"/>
+            </a:endParaRPr>
+          </a:p>
+          <a:p>
+            <a:pPr>
+              <a:lnSpc>
+                <a:spcPct val="150000"/>
+              </a:lnSpc>
+              <a:buNone/>
+            </a:pPr>
+            <a:endParaRPr lang="az-Latn-AZ" altLang="en-US" sz="1300">
+              <a:latin typeface="Arial" panose="020B0604020202020204" pitchFamily="34" charset="0"/>
+            </a:endParaRPr>
+          </a:p>
+          <a:p>
+            <a:pPr>
+              <a:lnSpc>
+                <a:spcPct val="150000"/>
+              </a:lnSpc>
+              <a:buNone/>
+            </a:pPr>
+            <a:endParaRPr kumimoji="0" lang="az-Latn-AZ" altLang="en-US" sz="1300" b="0" i="0" u="none" strike="noStrike" cap="none" normalizeH="0" baseline="0">
+              <a:ln>
+                <a:noFill/>
+              </a:ln>
+              <a:solidFill>
+                <a:schemeClr val="tx1"/>
+              </a:solidFill>
+              <a:effectLst/>
+              <a:latin typeface="Arial" panose="020B0604020202020204" pitchFamily="34" charset="0"/>
+            </a:endParaRPr>
+          </a:p>
+          <a:p>
+            <a:pPr>
+              <a:lnSpc>
+                <a:spcPct val="150000"/>
+              </a:lnSpc>
+              <a:buNone/>
+            </a:pPr>
+            <a:endParaRPr lang="az-Latn-AZ" altLang="en-US" sz="1300">
+              <a:latin typeface="Arial" panose="020B0604020202020204" pitchFamily="34" charset="0"/>
+            </a:endParaRPr>
+          </a:p>
+          <a:p>
+            <a:pPr>
+              <a:lnSpc>
+                <a:spcPct val="150000"/>
+              </a:lnSpc>
+              <a:buNone/>
+            </a:pPr>
+            <a:endParaRPr kumimoji="0" lang="az-Latn-AZ" altLang="en-US" sz="1300" b="0" i="0" u="none" strike="noStrike" cap="none" normalizeH="0" baseline="0">
+              <a:ln>
+                <a:noFill/>
+              </a:ln>
+              <a:solidFill>
+                <a:schemeClr val="tx1"/>
+              </a:solidFill>
+              <a:effectLst/>
+              <a:latin typeface="Arial" panose="020B0604020202020204" pitchFamily="34" charset="0"/>
+            </a:endParaRPr>
+          </a:p>
+          <a:p>
+            <a:pPr>
+              <a:lnSpc>
+                <a:spcPct val="150000"/>
+              </a:lnSpc>
+              <a:buNone/>
+            </a:pPr>
+            <a:endParaRPr lang="az-Latn-AZ" altLang="en-US" sz="1300">
+              <a:latin typeface="Arial" panose="020B0604020202020204" pitchFamily="34" charset="0"/>
+            </a:endParaRPr>
+          </a:p>
+          <a:p>
+            <a:pPr>
+              <a:lnSpc>
+                <a:spcPct val="150000"/>
+              </a:lnSpc>
+              <a:buNone/>
+            </a:pPr>
+            <a:endParaRPr kumimoji="0" lang="az-Latn-AZ" altLang="en-US" sz="1300" b="0" i="0" u="none" strike="noStrike" cap="none" normalizeH="0" baseline="0">
+              <a:ln>
+                <a:noFill/>
+              </a:ln>
+              <a:solidFill>
+                <a:schemeClr val="tx1"/>
+              </a:solidFill>
+              <a:effectLst/>
+              <a:latin typeface="Arial" panose="020B0604020202020204" pitchFamily="34" charset="0"/>
+            </a:endParaRPr>
+          </a:p>
+          <a:p>
+            <a:pPr>
+              <a:lnSpc>
+                <a:spcPct val="150000"/>
+              </a:lnSpc>
+              <a:buNone/>
+            </a:pPr>
+            <a:endParaRPr lang="az-Latn-AZ" altLang="en-US" sz="1300">
+              <a:latin typeface="Arial" panose="020B0604020202020204" pitchFamily="34" charset="0"/>
+            </a:endParaRPr>
+          </a:p>
+          <a:p>
+            <a:pPr>
+              <a:lnSpc>
+                <a:spcPct val="150000"/>
+              </a:lnSpc>
+              <a:buNone/>
+            </a:pPr>
+            <a:endParaRPr kumimoji="0" lang="en-US" altLang="en-US" sz="1300" b="0" i="0" u="none" strike="noStrike" cap="none" normalizeH="0" baseline="0">
+              <a:ln>
+                <a:noFill/>
+              </a:ln>
+              <a:solidFill>
+                <a:schemeClr val="tx1"/>
+              </a:solidFill>
+              <a:effectLst/>
+              <a:latin typeface="Arial" panose="020B0604020202020204" pitchFamily="34" charset="0"/>
+            </a:endParaRPr>
+          </a:p>
+          <a:p>
+            <a:pPr>
+              <a:lnSpc>
+                <a:spcPct val="150000"/>
+              </a:lnSpc>
+              <a:buNone/>
+            </a:pPr>
+            <a:r>
+              <a:rPr lang="en-US" altLang="en-US" sz="1300" b="1">
+                <a:solidFill>
+                  <a:srgbClr val="FF0000"/>
+                </a:solidFill>
+                <a:latin typeface="Arial" panose="020B0604020202020204" pitchFamily="34" charset="0"/>
+              </a:rPr>
+              <a:t>VACIB QEYD</a:t>
+            </a:r>
+            <a:r>
+              <a:rPr lang="en-US" altLang="en-US" sz="1300">
+                <a:latin typeface="Arial" panose="020B0604020202020204" pitchFamily="34" charset="0"/>
+              </a:rPr>
+              <a:t>: hal </a:t>
+            </a:r>
+            <a:r>
+              <a:rPr lang="az-Latn-AZ" altLang="en-US" sz="1300">
+                <a:latin typeface="Arial" panose="020B0604020202020204" pitchFamily="34" charset="0"/>
+              </a:rPr>
+              <a:t>hazırda pagination işləmir ( sağ şəkil ).</a:t>
             </a:r>
             <a:endParaRPr kumimoji="0" lang="en-US" altLang="en-US" sz="1300" b="0" i="0" u="none" strike="noStrike" cap="none" normalizeH="0" baseline="0">
               <a:ln>
@@ -4403,14 +4678,43 @@
         </p:nvPicPr>
         <p:blipFill>
           <a:blip r:embed="rId3"/>
+          <a:srcRect r="15194"/>
+          <a:stretch/>
+        </p:blipFill>
+        <p:spPr>
+          <a:xfrm>
+            <a:off x="0" y="846122"/>
+            <a:ext cx="6880670" cy="3530338"/>
+          </a:xfrm>
+          <a:prstGeom prst="rect">
+            <a:avLst/>
+          </a:prstGeom>
+        </p:spPr>
+      </p:pic>
+      <p:pic>
+        <p:nvPicPr>
+          <p:cNvPr id="5" name="Picture 4">
+            <a:extLst>
+              <a:ext uri="{FF2B5EF4-FFF2-40B4-BE49-F238E27FC236}">
+                <a16:creationId xmlns:a16="http://schemas.microsoft.com/office/drawing/2014/main" id="{93BC6189-A8FD-29A7-20FB-3BF033C70B78}"/>
+              </a:ext>
+            </a:extLst>
+          </p:cNvPr>
+          <p:cNvPicPr>
+            <a:picLocks noChangeAspect="1"/>
+          </p:cNvPicPr>
+          <p:nvPr/>
+        </p:nvPicPr>
+        <p:blipFill>
+          <a:blip r:embed="rId4"/>
           <a:stretch>
             <a:fillRect/>
           </a:stretch>
         </p:blipFill>
         <p:spPr>
           <a:xfrm>
-            <a:off x="0" y="1552987"/>
-            <a:ext cx="12192000" cy="5305013"/>
+            <a:off x="8287852" y="3685880"/>
+            <a:ext cx="3904148" cy="3172120"/>
           </a:xfrm>
           <a:prstGeom prst="rect">
             <a:avLst/>

</xml_diff>